<commit_message>
Add judge-defense + NotebookLM context; fix stale deck strings
- JUDGE_DEFENSE.md: full presentation prep -- memorised pitch, every judge
  question answered with spoken lines + measured backup, hard/trap questions,
  a live-demo runbook, and a pre-submission checklist.
- NOTEBOOKLM_CONTEXT.md: self-contained project briefing for generating a
  deck, every number pulled from the measured artifacts.
- src/make_deck.js: the architecture and bottom-line slides still carried
  German-Credit / "1,000 applicants" / "Deutschmarks" strings and a
  "logistic regression beats GBM" line from before the dataset switch. The
  data-driven fields had updated but these hardcoded strings had not, so the
  deck contradicted the rest of the submission. Now Taiwan / 30,000 / AUC
  0.78 / GBM-wins / fairness gap 0.28 -> 0.03, consistent everywhere.

Co-Authored-By: Claude Opus 4.8 <noreply@anthropic.com>
</commit_message>
<xml_diff>
--- a/PRESENTATION.pptx
+++ b/PRESENTATION.pptx
@@ -2684,7 +2684,7 @@
                 <a:ea typeface="Calibri" pitchFamily="34" charset="-122"/>
                 <a:cs typeface="Calibri" pitchFamily="34" charset="-120"/>
               </a:rPr>
-              <a:t>German Credit</a:t>
+              <a:t>Taiwan card data</a:t>
             </a:r>
             <a:endParaRPr lang="en-US" sz="1350" dirty="0"/>
           </a:p>
@@ -2723,7 +2723,7 @@
                 <a:ea typeface="Calibri" pitchFamily="34" charset="-122"/>
                 <a:cs typeface="Calibri" pitchFamily="34" charset="-120"/>
               </a:rPr>
-              <a:t>1,000 real applicants</a:t>
+              <a:t>30,000 accounts</a:t>
             </a:r>
             <a:endParaRPr lang="en-US" sz="1050" dirty="0"/>
           </a:p>
@@ -2740,7 +2740,7 @@
                 <a:ea typeface="Calibri" pitchFamily="34" charset="-122"/>
                 <a:cs typeface="Calibri" pitchFamily="34" charset="-120"/>
               </a:rPr>
-              <a:t>UCI Statlog</a:t>
+              <a:t>UCI, 2005</a:t>
             </a:r>
             <a:endParaRPr lang="en-US" sz="1050" dirty="0"/>
           </a:p>
@@ -2884,7 +2884,7 @@
                 <a:ea typeface="Calibri" pitchFamily="34" charset="-122"/>
                 <a:cs typeface="Calibri" pitchFamily="34" charset="-120"/>
               </a:rPr>
-              <a:t>P(default) per applicant</a:t>
+              <a:t>P(default) per account</a:t>
             </a:r>
             <a:endParaRPr lang="en-US" sz="1050" dirty="0"/>
           </a:p>
@@ -3797,7 +3797,7 @@
                 <a:ea typeface="Calibri" pitchFamily="34" charset="-122"/>
                 <a:cs typeface="Calibri" pitchFamily="34" charset="-120"/>
               </a:rPr>
-              <a:t>Fairness weight → approval-rate gap closes from −42% to −2.9%, and we can price it.</a:t>
+              <a:t>Fairness weight → approval-rate gap closes from 0.28 to 0.03, and we can price it.</a:t>
             </a:r>
             <a:endParaRPr lang="en-US" sz="1200" dirty="0"/>
           </a:p>
@@ -3876,7 +3876,7 @@
               <a:buNone/>
             </a:pPr>
             <a:r>
-              <a:rPr lang="en-US" sz="1700" b="1" dirty="0">
+              <a:rPr lang="en-US" sz="2000" b="1" dirty="0">
                 <a:solidFill>
                   <a:srgbClr val="1E2761"/>
                 </a:solidFill>
@@ -3884,9 +3884,9 @@
                 <a:ea typeface="Cambria" pitchFamily="34" charset="-122"/>
                 <a:cs typeface="Cambria" pitchFamily="34" charset="-120"/>
               </a:rPr>
-              <a:t>−42% → −2.9%</a:t>
-            </a:r>
-            <a:endParaRPr lang="en-US" sz="1700" dirty="0"/>
+              <a:t>0.28 → 0.03</a:t>
+            </a:r>
+            <a:endParaRPr lang="en-US" sz="2000" dirty="0"/>
           </a:p>
         </p:txBody>
       </p:sp>
@@ -4094,7 +4094,7 @@
                 <a:ea typeface="Calibri" pitchFamily="34" charset="-122"/>
                 <a:cs typeface="Calibri" pitchFamily="34" charset="-120"/>
               </a:rPr>
-              <a:t>We do not claim the model is fair. We claim we can put parity in the objective and tell you what it costs in Deutschmarks.</a:t>
+              <a:t>We do not claim the model is fair. We claim we can put parity in the objective and tell you what it costs -- about 4% of profit.</a:t>
             </a:r>
             <a:endParaRPr lang="en-US" sz="1150" dirty="0"/>
           </a:p>
@@ -6067,7 +6067,7 @@
                 <a:ea typeface="Calibri" pitchFamily="34" charset="-122"/>
                 <a:cs typeface="Calibri" pitchFamily="34" charset="-120"/>
               </a:rPr>
-              <a:t>Calibrated GBM on 1,000 real applicants. Logistic regression beats it — we report that.</a:t>
+              <a:t>Calibrated GBM on 30,000 real accounts, AUC 0.78. Beats logistic regression here -- reversed on small data.</a:t>
             </a:r>
             <a:endParaRPr lang="en-US" sz="1250" dirty="0"/>
           </a:p>

</xml_diff>